<commit_message>
Copy: we bellen op de beste dagen, niet elke werkdag
LINK. belt niet standaard elke werkdag. We kijken per branche wat
nodig is en wanneer het werkt, op basis van onze eigen data. Drie
plekken aangepast in alle decks:

- proces "Belstart": vanaf de eerste maandag bellen we op de dagen
  en dagdelen die in onze data het beste werken voor de branche
- pilot "Twaalf weken bellen": zelfde formulering, plus regionaal
  nummer op naam van de klant
- pilot-checklist: "Twaalf weken bellen op de beste momenten"

Geraakt: centreblock, kennismaking, loydd, mannenvan80, mediatribe,
mostwarenext, pilot, portrelo, slides (Techmetric3d), sparely,
spooker. Moyee brew sheet: etiket nu "op de juiste dagen vers
gebeld". Alle PDF's, PPTX'en en previews opnieuw gebouwd, PPTX-QA
geeft 0 teksten buiten kader en 0 ontbrekende teksten.

Co-Authored-By: Claude Opus 5 <noreply@anthropic.com>
Claude-Session: https://claude.ai/code/session_0141FN3f3hHkYQHTyvTJJGrw
</commit_message>
<xml_diff>
--- a/output/LINK. kennismaking CentreBlock.pptx
+++ b/output/LINK. kennismaking CentreBlock.pptx
@@ -5708,7 +5708,7 @@
                 <a:ea typeface="Arial" pitchFamily="34" charset="-122"/>
                 <a:cs typeface="Arial" pitchFamily="34" charset="-120"/>
               </a:rPr>
-              <a:t>Vanaf de eerste maandag na de kick-off bellen we dagelijks. Elke afspraak krijgt een bevestigingsmail naar de prospect en een overdracht met context naar jullie.</a:t>
+              <a:t>Vanaf de eerste maandag na de kick-off gaan we bellen, op de dagen en dagdelen die in onze data het beste werken voor jullie branche. Elke afspraak krijgt een bevestigingsmail naar de prospect en een overdracht met context naar jullie.</a:t>
             </a:r>
             <a:endParaRPr lang="en-US" sz="900" dirty="0"/>
           </a:p>
@@ -7913,7 +7913,7 @@
                 <a:ea typeface="Arial" pitchFamily="34" charset="-122"/>
                 <a:cs typeface="Arial" pitchFamily="34" charset="-120"/>
               </a:rPr>
-              <a:t>Elke werkdag bellen met een regionaal nummer op jullie naam. Elke week een rapportage, om de week evaluatie. Gaat het makkelijker of juist moeizamer, dan zitten we eerder om tafel en schakelen we direct.</a:t>
+              <a:t>We bellen op de dagen en dagdelen die in onze data het beste werken voor jullie branche, met een regionaal nummer op jullie naam. Elke week een rapportage, om de week evaluatie. Gaat het makkelijker of juist moeizamer, dan zitten we eerder om tafel en schakelen we direct.</a:t>
             </a:r>
             <a:endParaRPr lang="en-US" sz="875" dirty="0"/>
           </a:p>
@@ -8501,7 +8501,7 @@
                 <a:ea typeface="Arial" pitchFamily="34" charset="-122"/>
                 <a:cs typeface="Arial" pitchFamily="34" charset="-120"/>
               </a:rPr>
-              <a:t>Twaalf weken elke werkdag bellen</a:t>
+              <a:t>Twaalf weken bellen op de beste momenten</a:t>
             </a:r>
             <a:endParaRPr lang="en-US" sz="900" dirty="0"/>
           </a:p>

</xml_diff>

<commit_message>
CentreBlock: voorstel toegespitst na de kennismaking met Kees
Op basis van de mailwisseling met Kees Pronk, niet op de Fireflies-
transcriptie: die heeft het Nederlands als Engels verstaan en is
onbruikbaar.

- cover: "Voor Kees", en de sub benoemt de doelgroep die wij voor
  CentreBlock bellen (marketingteams en bureaus die moeten aantonen
  wat hun campagnes opleveren)
- wie wij zijn: fairchain koffieleverancier en AI-consultancy als
  bewijs, plus de link met software voor marketeers
- data en doelgroep, bellijst in de pilot: dezelfde doelgroep concreet
- kwalificatie: Fit op structureel marketingbudget met een team of
  bureau, Beslisser op marketingmanager, CMO of bureau-eigenaar
- kick-off en akkoord staan nu op naam van Kees

PDF, PPTX, previews en webdeck opnieuw gebouwd. Geen overloop,
0 teksten buiten kader, 0 ontbrekende teksten in de PPTX.

Co-Authored-By: Claude Opus 5 <noreply@anthropic.com>
Claude-Session: https://claude.ai/code/session_0141FN3f3hHkYQHTyvTJJGrw
</commit_message>
<xml_diff>
--- a/output/LINK. kennismaking CentreBlock.pptx
+++ b/output/LINK. kennismaking CentreBlock.pptx
@@ -2401,7 +2401,7 @@
                 <a:ea typeface="Arial" pitchFamily="34" charset="-122"/>
                 <a:cs typeface="Arial" pitchFamily="34" charset="-120"/>
               </a:rPr>
-              <a:t>VOOR CENTREBLOCK · SEPTEMBER 2026</a:t>
+              <a:t>VOOR KEES · CENTREBLOCK · SEPTEMBER 2026</a:t>
             </a:r>
             <a:endParaRPr lang="en-US" sz="950" dirty="0"/>
           </a:p>
@@ -2519,7 +2519,7 @@
                 <a:ea typeface="Arial" pitchFamily="34" charset="-122"/>
                 <a:cs typeface="Arial" pitchFamily="34" charset="-120"/>
               </a:rPr>
-              <a:t>Wat LINK. voor CentreBlock kan betekenen: structureel gesprekken met bedrijven die jullie nog niet kennen, en na twaalf weken een plan op basis van echte cijfers.</a:t>
+              <a:t>Wat LINK. voor CentreBlock kan betekenen: structureel aan tafel bij marketingteams en bureaus die willen aantonen welke campagnes echt omzet opleveren, en na twaalf weken een plan op basis van echte cijfers.</a:t>
             </a:r>
             <a:endParaRPr lang="en-US" sz="1400" dirty="0"/>
           </a:p>
@@ -3077,7 +3077,7 @@
                 <a:ea typeface="Arial" pitchFamily="34" charset="-122"/>
                 <a:cs typeface="Arial" pitchFamily="34" charset="-120"/>
               </a:rPr>
-              <a:t>Jullie geven akkoord op het pilotvoorstel.</a:t>
+              <a:t>Kees geeft akkoord op het pilotvoorstel.</a:t>
             </a:r>
             <a:endParaRPr lang="en-US" sz="1100" dirty="0"/>
           </a:p>
@@ -3926,7 +3926,7 @@
                 <a:ea typeface="Arial" pitchFamily="34" charset="-122"/>
                 <a:cs typeface="Arial" pitchFamily="34" charset="-120"/>
               </a:rPr>
-              <a:t>We werken voor bedrijven met een sterke B2B-propositie, in uiteenlopende branches. Geen bureau op afstand, maar een partner die elke week met je schakelt.</a:t>
+              <a:t>We werken voor bedrijven met een sterke B2B-propositie, van een fairchain koffieleverancier tot een AI-consultancy. Software die het werk van marketeers lichter maakt past daar goed bij. Geen bureau op afstand, maar een partner die elke week met je schakelt.</a:t>
             </a:r>
             <a:endParaRPr lang="en-US" sz="1350" dirty="0"/>
           </a:p>
@@ -4792,7 +4792,7 @@
                 <a:ea typeface="Arial" pitchFamily="34" charset="-122"/>
                 <a:cs typeface="Arial" pitchFamily="34" charset="-120"/>
               </a:rPr>
-              <a:t>Wij bouwen de bellijst op basis van jullie ideale klant: branche, grootte, regio en functie. Bestaande relaties en uitsluitingen halen we er vooraf uit.</a:t>
+              <a:t>Wij bouwen de bellijst op jullie ideale klant: bedrijven en bureaus met een marketingbudget dat verantwoord moet worden. Op branche, grootte, regio en functie. Bestaande relaties en uitsluitingen halen we er vooraf uit.</a:t>
             </a:r>
             <a:endParaRPr lang="en-US" sz="950" dirty="0"/>
           </a:p>
@@ -6762,7 +6762,7 @@
                 <a:ea typeface="Arial" pitchFamily="34" charset="-122"/>
                 <a:cs typeface="Arial" pitchFamily="34" charset="-120"/>
               </a:rPr>
-              <a:t>Het bedrijf past: branche, omvang en situatie voldoen aan de criteria uit de kick-off.</a:t>
+              <a:t>Het bedrijf past: er gaat structureel geld naar marketing en er is een team of bureau dat de campagnes draait.</a:t>
             </a:r>
             <a:endParaRPr lang="en-US" sz="1050" dirty="0"/>
           </a:p>
@@ -7060,7 +7060,7 @@
                 <a:ea typeface="Arial" pitchFamily="34" charset="-122"/>
                 <a:cs typeface="Arial" pitchFamily="34" charset="-120"/>
               </a:rPr>
-              <a:t>De afspraak staat met iemand die over de aankoop gaat of daar direct invloed op heeft.</a:t>
+              <a:t>De afspraak staat met de marketingmanager, de CMO of de eigenaar van het bureau. Iemand die over tooling gaat of daar direct invloed op heeft.</a:t>
             </a:r>
             <a:endParaRPr lang="en-US" sz="1050" dirty="0"/>
           </a:p>
@@ -7741,7 +7741,7 @@
                 <a:ea typeface="Arial" pitchFamily="34" charset="-122"/>
                 <a:cs typeface="Arial" pitchFamily="34" charset="-120"/>
               </a:rPr>
-              <a:t>Wij bouwen de bellijst op jullie ideale klant: branche, grootte, regio en functie. Bestaande relaties en uitsluitingen gaan er vooraf uit.</a:t>
+              <a:t>Wij bouwen de bellijst op jullie ideale klant: marketingteams en bureaus die moeten aantonen wat hun campagnes opleveren. Bestaande relaties en uitsluitingen gaan er vooraf uit.</a:t>
             </a:r>
             <a:endParaRPr lang="en-US" sz="875" dirty="0"/>
           </a:p>
@@ -10079,7 +10079,7 @@
                 <a:ea typeface="Arial" pitchFamily="34" charset="-122"/>
                 <a:cs typeface="Arial" pitchFamily="34" charset="-120"/>
               </a:rPr>
-              <a:t>Anderhalf tot twee uur met de beslisser en degene die de afspraken gaat voeren.</a:t>
+              <a:t>Anderhalf tot twee uur met Kees en degene die de afspraken gaat voeren.</a:t>
             </a:r>
             <a:endParaRPr lang="en-US" sz="1050" dirty="0"/>
           </a:p>

</xml_diff>